<commit_message>
added week 1 - update2
</commit_message>
<xml_diff>
--- a/topic01-objects-and-classes/unit-1/talk-1-bluej/getting-started-bluej.pptx
+++ b/topic01-objects-and-classes/unit-1/talk-1-bluej/getting-started-bluej.pptx
@@ -5,7 +5,7 @@
     <p:sldMasterId id="2147483660" r:id="rId1"/>
   </p:sldMasterIdLst>
   <p:notesMasterIdLst>
-    <p:notesMasterId r:id="rId18"/>
+    <p:notesMasterId r:id="rId20"/>
   </p:notesMasterIdLst>
   <p:sldIdLst>
     <p:sldId id="325" r:id="rId2"/>
@@ -17,13 +17,15 @@
     <p:sldId id="286" r:id="rId8"/>
     <p:sldId id="667" r:id="rId9"/>
     <p:sldId id="680" r:id="rId10"/>
-    <p:sldId id="670" r:id="rId11"/>
-    <p:sldId id="678" r:id="rId12"/>
-    <p:sldId id="690" r:id="rId13"/>
-    <p:sldId id="673" r:id="rId14"/>
-    <p:sldId id="691" r:id="rId15"/>
-    <p:sldId id="679" r:id="rId16"/>
-    <p:sldId id="347" r:id="rId17"/>
+    <p:sldId id="693" r:id="rId11"/>
+    <p:sldId id="692" r:id="rId12"/>
+    <p:sldId id="670" r:id="rId13"/>
+    <p:sldId id="678" r:id="rId14"/>
+    <p:sldId id="690" r:id="rId15"/>
+    <p:sldId id="673" r:id="rId16"/>
+    <p:sldId id="691" r:id="rId17"/>
+    <p:sldId id="679" r:id="rId18"/>
+    <p:sldId id="347" r:id="rId19"/>
   </p:sldIdLst>
   <p:sldSz cx="12192000" cy="6858000"/>
   <p:notesSz cx="6858000" cy="9144000"/>
@@ -4749,7 +4751,13 @@
   <p:cSld>
     <p:spTree>
       <p:nvGrpSpPr>
-        <p:cNvPr id="1" name=""/>
+        <p:cNvPr id="1" name="">
+          <a:extLst>
+            <a:ext uri="{FF2B5EF4-FFF2-40B4-BE49-F238E27FC236}">
+              <a16:creationId xmlns:a16="http://schemas.microsoft.com/office/drawing/2014/main" id="{E98A1368-C4F3-3755-BFA2-4897EA048EBA}"/>
+            </a:ext>
+          </a:extLst>
+        </p:cNvPr>
         <p:cNvGrpSpPr/>
         <p:nvPr/>
       </p:nvGrpSpPr>
@@ -4766,7 +4774,7 @@
           <p:cNvPr id="2" name="Title 1">
             <a:extLst>
               <a:ext uri="{FF2B5EF4-FFF2-40B4-BE49-F238E27FC236}">
-                <a16:creationId xmlns:a16="http://schemas.microsoft.com/office/drawing/2014/main" id="{E6087A9B-75BD-2B7B-ED53-385535B5B8EB}"/>
+                <a16:creationId xmlns:a16="http://schemas.microsoft.com/office/drawing/2014/main" id="{0FD9B550-1A00-C14E-0084-D0A9A74ED017}"/>
               </a:ext>
             </a:extLst>
           </p:cNvPr>
@@ -4794,7 +4802,7 @@
           <p:cNvPr id="6" name="Content Placeholder 5">
             <a:extLst>
               <a:ext uri="{FF2B5EF4-FFF2-40B4-BE49-F238E27FC236}">
-                <a16:creationId xmlns:a16="http://schemas.microsoft.com/office/drawing/2014/main" id="{F245F4E7-767C-A09E-16B7-7ABF4139C6B6}"/>
+                <a16:creationId xmlns:a16="http://schemas.microsoft.com/office/drawing/2014/main" id="{2DAC2DC8-CE43-6376-0541-6EEABE3B40D6}"/>
               </a:ext>
             </a:extLst>
           </p:cNvPr>
@@ -4821,18 +4829,6 @@
             </a:r>
           </a:p>
           <a:p>
-            <a:r>
-              <a:rPr lang="en-IE" dirty="0"/>
-              <a:t>Give your project a name and location, press OK</a:t>
-            </a:r>
-          </a:p>
-          <a:p>
-            <a:r>
-              <a:rPr lang="en-IE" dirty="0"/>
-              <a:t>Click on New Class, and name it</a:t>
-            </a:r>
-          </a:p>
-          <a:p>
             <a:endParaRPr lang="en-IE" dirty="0"/>
           </a:p>
           <a:p>
@@ -4845,7 +4841,7 @@
           <p:cNvPr id="9" name="Picture 8">
             <a:extLst>
               <a:ext uri="{FF2B5EF4-FFF2-40B4-BE49-F238E27FC236}">
-                <a16:creationId xmlns:a16="http://schemas.microsoft.com/office/drawing/2014/main" id="{49B2F710-7D84-3F69-1758-EA65A4715211}"/>
+                <a16:creationId xmlns:a16="http://schemas.microsoft.com/office/drawing/2014/main" id="{CFA4C8DB-8BF1-9EE6-4D50-15C7350E487D}"/>
               </a:ext>
             </a:extLst>
           </p:cNvPr>
@@ -4870,100 +4866,10 @@
           </a:prstGeom>
         </p:spPr>
       </p:pic>
-      <p:pic>
-        <p:nvPicPr>
-          <p:cNvPr id="11" name="Picture 10">
-            <a:extLst>
-              <a:ext uri="{FF2B5EF4-FFF2-40B4-BE49-F238E27FC236}">
-                <a16:creationId xmlns:a16="http://schemas.microsoft.com/office/drawing/2014/main" id="{C2E76B53-B3BF-9360-E555-CFC2FAD26B79}"/>
-              </a:ext>
-            </a:extLst>
-          </p:cNvPr>
-          <p:cNvPicPr>
-            <a:picLocks noChangeAspect="1"/>
-          </p:cNvPicPr>
-          <p:nvPr/>
-        </p:nvPicPr>
-        <p:blipFill>
-          <a:blip r:embed="rId3"/>
-          <a:stretch>
-            <a:fillRect/>
-          </a:stretch>
-        </p:blipFill>
-        <p:spPr>
-          <a:xfrm>
-            <a:off x="5943600" y="1711008"/>
-            <a:ext cx="4277322" cy="1943371"/>
-          </a:xfrm>
-          <a:prstGeom prst="rect">
-            <a:avLst/>
-          </a:prstGeom>
-        </p:spPr>
-      </p:pic>
-      <p:pic>
-        <p:nvPicPr>
-          <p:cNvPr id="15" name="Picture 14">
-            <a:extLst>
-              <a:ext uri="{FF2B5EF4-FFF2-40B4-BE49-F238E27FC236}">
-                <a16:creationId xmlns:a16="http://schemas.microsoft.com/office/drawing/2014/main" id="{9C8697CD-C7FD-0740-BAE5-5A901F8131AD}"/>
-              </a:ext>
-            </a:extLst>
-          </p:cNvPr>
-          <p:cNvPicPr>
-            <a:picLocks noChangeAspect="1"/>
-          </p:cNvPicPr>
-          <p:nvPr/>
-        </p:nvPicPr>
-        <p:blipFill>
-          <a:blip r:embed="rId4"/>
-          <a:stretch>
-            <a:fillRect/>
-          </a:stretch>
-        </p:blipFill>
-        <p:spPr>
-          <a:xfrm>
-            <a:off x="7086600" y="1219200"/>
-            <a:ext cx="2476846" cy="4134427"/>
-          </a:xfrm>
-          <a:prstGeom prst="rect">
-            <a:avLst/>
-          </a:prstGeom>
-        </p:spPr>
-      </p:pic>
-      <p:pic>
-        <p:nvPicPr>
-          <p:cNvPr id="17" name="Picture 16">
-            <a:extLst>
-              <a:ext uri="{FF2B5EF4-FFF2-40B4-BE49-F238E27FC236}">
-                <a16:creationId xmlns:a16="http://schemas.microsoft.com/office/drawing/2014/main" id="{23025BBB-B915-17E8-078C-5054ADA8FF1F}"/>
-              </a:ext>
-            </a:extLst>
-          </p:cNvPr>
-          <p:cNvPicPr>
-            <a:picLocks noChangeAspect="1"/>
-          </p:cNvPicPr>
-          <p:nvPr/>
-        </p:nvPicPr>
-        <p:blipFill>
-          <a:blip r:embed="rId5"/>
-          <a:stretch>
-            <a:fillRect/>
-          </a:stretch>
-        </p:blipFill>
-        <p:spPr>
-          <a:xfrm>
-            <a:off x="4937760" y="881867"/>
-            <a:ext cx="7411484" cy="5611008"/>
-          </a:xfrm>
-          <a:prstGeom prst="rect">
-            <a:avLst/>
-          </a:prstGeom>
-        </p:spPr>
-      </p:pic>
     </p:spTree>
     <p:extLst>
       <p:ext uri="{BB962C8B-B14F-4D97-AF65-F5344CB8AC3E}">
-        <p14:creationId xmlns:p14="http://schemas.microsoft.com/office/powerpoint/2010/main" val="3661995497"/>
+        <p14:creationId xmlns:p14="http://schemas.microsoft.com/office/powerpoint/2010/main" val="705394113"/>
       </p:ext>
     </p:extLst>
   </p:cSld>
@@ -5048,6 +4954,277 @@
                                   </p:childTnLst>
                                 </p:cTn>
                               </p:par>
+                              <p:par>
+                                <p:cTn id="9" presetID="1" presetClass="exit" presetSubtype="0" fill="hold" nodeType="withEffect">
+                                  <p:stCondLst>
+                                    <p:cond delay="0"/>
+                                  </p:stCondLst>
+                                  <p:childTnLst>
+                                    <p:set>
+                                      <p:cBhvr>
+                                        <p:cTn id="10" dur="1" fill="hold">
+                                          <p:stCondLst>
+                                            <p:cond delay="0"/>
+                                          </p:stCondLst>
+                                        </p:cTn>
+                                        <p:tgtEl>
+                                          <p:spTgt spid="9"/>
+                                        </p:tgtEl>
+                                        <p:attrNameLst>
+                                          <p:attrName>style.visibility</p:attrName>
+                                        </p:attrNameLst>
+                                      </p:cBhvr>
+                                      <p:to>
+                                        <p:strVal val="hidden"/>
+                                      </p:to>
+                                    </p:set>
+                                  </p:childTnLst>
+                                </p:cTn>
+                              </p:par>
+                            </p:childTnLst>
+                          </p:cTn>
+                        </p:par>
+                      </p:childTnLst>
+                    </p:cTn>
+                  </p:par>
+                </p:childTnLst>
+              </p:cTn>
+              <p:prevCondLst>
+                <p:cond evt="onPrev" delay="0">
+                  <p:tgtEl>
+                    <p:sldTgt/>
+                  </p:tgtEl>
+                </p:cond>
+              </p:prevCondLst>
+              <p:nextCondLst>
+                <p:cond evt="onNext" delay="0">
+                  <p:tgtEl>
+                    <p:sldTgt/>
+                  </p:tgtEl>
+                </p:cond>
+              </p:nextCondLst>
+            </p:seq>
+          </p:childTnLst>
+        </p:cTn>
+      </p:par>
+    </p:tnLst>
+    <p:bldLst>
+      <p:bldP spid="6" grpId="0" uiExpand="1" build="p"/>
+    </p:bldLst>
+  </p:timing>
+</p:sld>
+</file>
+
+<file path=ppt/slides/slide11.xml><?xml version="1.0" encoding="utf-8"?>
+<p:sld xmlns:a="http://schemas.openxmlformats.org/drawingml/2006/main" xmlns:r="http://schemas.openxmlformats.org/officeDocument/2006/relationships" xmlns:p="http://schemas.openxmlformats.org/presentationml/2006/main">
+  <p:cSld>
+    <p:spTree>
+      <p:nvGrpSpPr>
+        <p:cNvPr id="1" name="">
+          <a:extLst>
+            <a:ext uri="{FF2B5EF4-FFF2-40B4-BE49-F238E27FC236}">
+              <a16:creationId xmlns:a16="http://schemas.microsoft.com/office/drawing/2014/main" id="{D9909A26-C23E-05D0-B687-F14D425475D6}"/>
+            </a:ext>
+          </a:extLst>
+        </p:cNvPr>
+        <p:cNvGrpSpPr/>
+        <p:nvPr/>
+      </p:nvGrpSpPr>
+      <p:grpSpPr>
+        <a:xfrm>
+          <a:off x="0" y="0"/>
+          <a:ext cx="0" cy="0"/>
+          <a:chOff x="0" y="0"/>
+          <a:chExt cx="0" cy="0"/>
+        </a:xfrm>
+      </p:grpSpPr>
+      <p:sp>
+        <p:nvSpPr>
+          <p:cNvPr id="2" name="Title 1">
+            <a:extLst>
+              <a:ext uri="{FF2B5EF4-FFF2-40B4-BE49-F238E27FC236}">
+                <a16:creationId xmlns:a16="http://schemas.microsoft.com/office/drawing/2014/main" id="{D5DC0DA8-BCD3-EF59-968A-E7BC523F8FC1}"/>
+              </a:ext>
+            </a:extLst>
+          </p:cNvPr>
+          <p:cNvSpPr>
+            <a:spLocks noGrp="1"/>
+          </p:cNvSpPr>
+          <p:nvPr>
+            <p:ph type="title"/>
+          </p:nvPr>
+        </p:nvSpPr>
+        <p:spPr/>
+        <p:txBody>
+          <a:bodyPr/>
+          <a:lstStyle/>
+          <a:p>
+            <a:r>
+              <a:rPr lang="en-US" dirty="0"/>
+              <a:t>New Java Project</a:t>
+            </a:r>
+          </a:p>
+        </p:txBody>
+      </p:sp>
+      <p:sp>
+        <p:nvSpPr>
+          <p:cNvPr id="6" name="Content Placeholder 5">
+            <a:extLst>
+              <a:ext uri="{FF2B5EF4-FFF2-40B4-BE49-F238E27FC236}">
+                <a16:creationId xmlns:a16="http://schemas.microsoft.com/office/drawing/2014/main" id="{31601A54-2A75-E90D-0C18-2653F5E4BB0F}"/>
+              </a:ext>
+            </a:extLst>
+          </p:cNvPr>
+          <p:cNvSpPr>
+            <a:spLocks noGrp="1"/>
+          </p:cNvSpPr>
+          <p:nvPr>
+            <p:ph idx="1"/>
+          </p:nvPr>
+        </p:nvSpPr>
+        <p:spPr>
+          <a:xfrm>
+            <a:off x="838200" y="1825625"/>
+            <a:ext cx="3886200" cy="4351338"/>
+          </a:xfrm>
+        </p:spPr>
+        <p:txBody>
+          <a:bodyPr/>
+          <a:lstStyle/>
+          <a:p>
+            <a:r>
+              <a:rPr lang="en-IE" dirty="0"/>
+              <a:t>Give your project a name and location, press OK</a:t>
+            </a:r>
+          </a:p>
+          <a:p>
+            <a:endParaRPr lang="en-IE" dirty="0"/>
+          </a:p>
+          <a:p>
+            <a:endParaRPr lang="en-IE" dirty="0"/>
+          </a:p>
+        </p:txBody>
+      </p:sp>
+      <p:pic>
+        <p:nvPicPr>
+          <p:cNvPr id="9" name="Picture 8">
+            <a:extLst>
+              <a:ext uri="{FF2B5EF4-FFF2-40B4-BE49-F238E27FC236}">
+                <a16:creationId xmlns:a16="http://schemas.microsoft.com/office/drawing/2014/main" id="{A923AFCF-F5F5-156A-B508-D046A5F98AD0}"/>
+              </a:ext>
+            </a:extLst>
+          </p:cNvPr>
+          <p:cNvPicPr>
+            <a:picLocks noChangeAspect="1"/>
+          </p:cNvPicPr>
+          <p:nvPr/>
+        </p:nvPicPr>
+        <p:blipFill>
+          <a:blip r:embed="rId2"/>
+          <a:stretch>
+            <a:fillRect/>
+          </a:stretch>
+        </p:blipFill>
+        <p:spPr>
+          <a:xfrm>
+            <a:off x="4953000" y="762000"/>
+            <a:ext cx="7440063" cy="5582429"/>
+          </a:xfrm>
+          <a:prstGeom prst="rect">
+            <a:avLst/>
+          </a:prstGeom>
+        </p:spPr>
+      </p:pic>
+      <p:pic>
+        <p:nvPicPr>
+          <p:cNvPr id="11" name="Picture 10">
+            <a:extLst>
+              <a:ext uri="{FF2B5EF4-FFF2-40B4-BE49-F238E27FC236}">
+                <a16:creationId xmlns:a16="http://schemas.microsoft.com/office/drawing/2014/main" id="{E42314FF-C562-5006-0D58-43EEB0234BB5}"/>
+              </a:ext>
+            </a:extLst>
+          </p:cNvPr>
+          <p:cNvPicPr>
+            <a:picLocks noChangeAspect="1"/>
+          </p:cNvPicPr>
+          <p:nvPr/>
+        </p:nvPicPr>
+        <p:blipFill>
+          <a:blip r:embed="rId3"/>
+          <a:stretch>
+            <a:fillRect/>
+          </a:stretch>
+        </p:blipFill>
+        <p:spPr>
+          <a:xfrm>
+            <a:off x="6534370" y="2362200"/>
+            <a:ext cx="4277322" cy="1943371"/>
+          </a:xfrm>
+          <a:prstGeom prst="rect">
+            <a:avLst/>
+          </a:prstGeom>
+        </p:spPr>
+      </p:pic>
+    </p:spTree>
+    <p:extLst>
+      <p:ext uri="{BB962C8B-B14F-4D97-AF65-F5344CB8AC3E}">
+        <p14:creationId xmlns:p14="http://schemas.microsoft.com/office/powerpoint/2010/main" val="3797553846"/>
+      </p:ext>
+    </p:extLst>
+  </p:cSld>
+  <p:clrMapOvr>
+    <a:masterClrMapping/>
+  </p:clrMapOvr>
+  <p:timing>
+    <p:tnLst>
+      <p:par>
+        <p:cTn id="1" dur="indefinite" restart="never" nodeType="tmRoot">
+          <p:childTnLst>
+            <p:seq concurrent="1" nextAc="seek">
+              <p:cTn id="2" dur="indefinite" nodeType="mainSeq">
+                <p:childTnLst>
+                  <p:par>
+                    <p:cTn id="3" fill="hold">
+                      <p:stCondLst>
+                        <p:cond delay="indefinite"/>
+                        <p:cond evt="onBegin" delay="0">
+                          <p:tn val="2"/>
+                        </p:cond>
+                      </p:stCondLst>
+                      <p:childTnLst>
+                        <p:par>
+                          <p:cTn id="4" fill="hold">
+                            <p:stCondLst>
+                              <p:cond delay="0"/>
+                            </p:stCondLst>
+                            <p:childTnLst>
+                              <p:par>
+                                <p:cTn id="5" presetID="1" presetClass="entr" presetSubtype="0" fill="hold" nodeType="withEffect">
+                                  <p:stCondLst>
+                                    <p:cond delay="0"/>
+                                  </p:stCondLst>
+                                  <p:childTnLst>
+                                    <p:set>
+                                      <p:cBhvr>
+                                        <p:cTn id="6" dur="1" fill="hold">
+                                          <p:stCondLst>
+                                            <p:cond delay="0"/>
+                                          </p:stCondLst>
+                                        </p:cTn>
+                                        <p:tgtEl>
+                                          <p:spTgt spid="9"/>
+                                        </p:tgtEl>
+                                        <p:attrNameLst>
+                                          <p:attrName>style.visibility</p:attrName>
+                                        </p:attrNameLst>
+                                      </p:cBhvr>
+                                      <p:to>
+                                        <p:strVal val="visible"/>
+                                      </p:to>
+                                    </p:set>
+                                  </p:childTnLst>
+                                </p:cTn>
+                              </p:par>
                             </p:childTnLst>
                           </p:cTn>
                         </p:par>
@@ -5055,26 +5232,26 @@
                     </p:cTn>
                   </p:par>
                   <p:par>
-                    <p:cTn id="9" fill="hold">
+                    <p:cTn id="7" fill="hold">
                       <p:stCondLst>
                         <p:cond delay="indefinite"/>
                       </p:stCondLst>
                       <p:childTnLst>
                         <p:par>
-                          <p:cTn id="10" fill="hold">
+                          <p:cTn id="8" fill="hold">
                             <p:stCondLst>
                               <p:cond delay="0"/>
                             </p:stCondLst>
                             <p:childTnLst>
                               <p:par>
-                                <p:cTn id="11" presetID="1" presetClass="entr" presetSubtype="0" fill="hold" grpId="0" nodeType="clickEffect">
+                                <p:cTn id="9" presetID="1" presetClass="entr" presetSubtype="0" fill="hold" grpId="0" nodeType="clickEffect">
                                   <p:stCondLst>
                                     <p:cond delay="0"/>
                                   </p:stCondLst>
                                   <p:childTnLst>
                                     <p:set>
                                       <p:cBhvr>
-                                        <p:cTn id="12" dur="1" fill="hold">
+                                        <p:cTn id="10" dur="1" fill="hold">
                                           <p:stCondLst>
                                             <p:cond delay="0"/>
                                           </p:stCondLst>
@@ -5082,7 +5259,7 @@
                                         <p:tgtEl>
                                           <p:spTgt spid="6">
                                             <p:txEl>
-                                              <p:pRg st="1" end="1"/>
+                                              <p:pRg st="0" end="0"/>
                                             </p:txEl>
                                           </p:spTgt>
                                         </p:tgtEl>
@@ -5098,14 +5275,14 @@
                                 </p:cTn>
                               </p:par>
                               <p:par>
-                                <p:cTn id="13" presetID="1" presetClass="exit" presetSubtype="0" fill="hold" nodeType="withEffect">
+                                <p:cTn id="11" presetID="1" presetClass="exit" presetSubtype="0" fill="hold" nodeType="withEffect">
                                   <p:stCondLst>
                                     <p:cond delay="0"/>
                                   </p:stCondLst>
                                   <p:childTnLst>
                                     <p:set>
                                       <p:cBhvr>
-                                        <p:cTn id="14" dur="1" fill="hold">
+                                        <p:cTn id="12" dur="1" fill="hold">
                                           <p:stCondLst>
                                             <p:cond delay="0"/>
                                           </p:stCondLst>
@@ -5125,14 +5302,14 @@
                                 </p:cTn>
                               </p:par>
                               <p:par>
-                                <p:cTn id="15" presetID="1" presetClass="entr" presetSubtype="0" fill="hold" nodeType="withEffect">
+                                <p:cTn id="13" presetID="1" presetClass="entr" presetSubtype="0" fill="hold" nodeType="withEffect">
                                   <p:stCondLst>
                                     <p:cond delay="0"/>
                                   </p:stCondLst>
                                   <p:childTnLst>
                                     <p:set>
                                       <p:cBhvr>
-                                        <p:cTn id="16" dur="1" fill="hold">
+                                        <p:cTn id="14" dur="1" fill="hold">
                                           <p:stCondLst>
                                             <p:cond delay="0"/>
                                           </p:stCondLst>
@@ -5151,64 +5328,15 @@
                                   </p:childTnLst>
                                 </p:cTn>
                               </p:par>
-                            </p:childTnLst>
-                          </p:cTn>
-                        </p:par>
-                      </p:childTnLst>
-                    </p:cTn>
-                  </p:par>
-                  <p:par>
-                    <p:cTn id="17" fill="hold">
-                      <p:stCondLst>
-                        <p:cond delay="indefinite"/>
-                      </p:stCondLst>
-                      <p:childTnLst>
-                        <p:par>
-                          <p:cTn id="18" fill="hold">
-                            <p:stCondLst>
-                              <p:cond delay="0"/>
-                            </p:stCondLst>
-                            <p:childTnLst>
                               <p:par>
-                                <p:cTn id="19" presetID="1" presetClass="entr" presetSubtype="0" fill="hold" grpId="0" nodeType="clickEffect">
+                                <p:cTn id="15" presetID="1" presetClass="exit" presetSubtype="0" fill="hold" nodeType="withEffect">
                                   <p:stCondLst>
                                     <p:cond delay="0"/>
                                   </p:stCondLst>
                                   <p:childTnLst>
                                     <p:set>
                                       <p:cBhvr>
-                                        <p:cTn id="20" dur="1" fill="hold">
-                                          <p:stCondLst>
-                                            <p:cond delay="0"/>
-                                          </p:stCondLst>
-                                        </p:cTn>
-                                        <p:tgtEl>
-                                          <p:spTgt spid="6">
-                                            <p:txEl>
-                                              <p:pRg st="2" end="2"/>
-                                            </p:txEl>
-                                          </p:spTgt>
-                                        </p:tgtEl>
-                                        <p:attrNameLst>
-                                          <p:attrName>style.visibility</p:attrName>
-                                        </p:attrNameLst>
-                                      </p:cBhvr>
-                                      <p:to>
-                                        <p:strVal val="visible"/>
-                                      </p:to>
-                                    </p:set>
-                                  </p:childTnLst>
-                                </p:cTn>
-                              </p:par>
-                              <p:par>
-                                <p:cTn id="21" presetID="1" presetClass="exit" presetSubtype="0" fill="hold" nodeType="withEffect">
-                                  <p:stCondLst>
-                                    <p:cond delay="0"/>
-                                  </p:stCondLst>
-                                  <p:childTnLst>
-                                    <p:set>
-                                      <p:cBhvr>
-                                        <p:cTn id="22" dur="1" fill="hold">
+                                        <p:cTn id="16" dur="1" fill="hold">
                                           <p:stCondLst>
                                             <p:cond delay="0"/>
                                           </p:stCondLst>
@@ -5230,21 +5358,260 @@
                             </p:childTnLst>
                           </p:cTn>
                         </p:par>
+                      </p:childTnLst>
+                    </p:cTn>
+                  </p:par>
+                </p:childTnLst>
+              </p:cTn>
+              <p:prevCondLst>
+                <p:cond evt="onPrev" delay="0">
+                  <p:tgtEl>
+                    <p:sldTgt/>
+                  </p:tgtEl>
+                </p:cond>
+              </p:prevCondLst>
+              <p:nextCondLst>
+                <p:cond evt="onNext" delay="0">
+                  <p:tgtEl>
+                    <p:sldTgt/>
+                  </p:tgtEl>
+                </p:cond>
+              </p:nextCondLst>
+            </p:seq>
+          </p:childTnLst>
+        </p:cTn>
+      </p:par>
+    </p:tnLst>
+    <p:bldLst>
+      <p:bldP spid="6" grpId="0" uiExpand="1" build="p"/>
+    </p:bldLst>
+  </p:timing>
+</p:sld>
+</file>
+
+<file path=ppt/slides/slide12.xml><?xml version="1.0" encoding="utf-8"?>
+<p:sld xmlns:a="http://schemas.openxmlformats.org/drawingml/2006/main" xmlns:r="http://schemas.openxmlformats.org/officeDocument/2006/relationships" xmlns:p="http://schemas.openxmlformats.org/presentationml/2006/main">
+  <p:cSld>
+    <p:spTree>
+      <p:nvGrpSpPr>
+        <p:cNvPr id="1" name=""/>
+        <p:cNvGrpSpPr/>
+        <p:nvPr/>
+      </p:nvGrpSpPr>
+      <p:grpSpPr>
+        <a:xfrm>
+          <a:off x="0" y="0"/>
+          <a:ext cx="0" cy="0"/>
+          <a:chOff x="0" y="0"/>
+          <a:chExt cx="0" cy="0"/>
+        </a:xfrm>
+      </p:grpSpPr>
+      <p:sp>
+        <p:nvSpPr>
+          <p:cNvPr id="2" name="Title 1">
+            <a:extLst>
+              <a:ext uri="{FF2B5EF4-FFF2-40B4-BE49-F238E27FC236}">
+                <a16:creationId xmlns:a16="http://schemas.microsoft.com/office/drawing/2014/main" id="{E6087A9B-75BD-2B7B-ED53-385535B5B8EB}"/>
+              </a:ext>
+            </a:extLst>
+          </p:cNvPr>
+          <p:cNvSpPr>
+            <a:spLocks noGrp="1"/>
+          </p:cNvSpPr>
+          <p:nvPr>
+            <p:ph type="title"/>
+          </p:nvPr>
+        </p:nvSpPr>
+        <p:spPr/>
+        <p:txBody>
+          <a:bodyPr/>
+          <a:lstStyle/>
+          <a:p>
+            <a:r>
+              <a:rPr lang="en-US" dirty="0"/>
+              <a:t>New Java Project</a:t>
+            </a:r>
+          </a:p>
+        </p:txBody>
+      </p:sp>
+      <p:sp>
+        <p:nvSpPr>
+          <p:cNvPr id="6" name="Content Placeholder 5">
+            <a:extLst>
+              <a:ext uri="{FF2B5EF4-FFF2-40B4-BE49-F238E27FC236}">
+                <a16:creationId xmlns:a16="http://schemas.microsoft.com/office/drawing/2014/main" id="{F245F4E7-767C-A09E-16B7-7ABF4139C6B6}"/>
+              </a:ext>
+            </a:extLst>
+          </p:cNvPr>
+          <p:cNvSpPr>
+            <a:spLocks noGrp="1"/>
+          </p:cNvSpPr>
+          <p:nvPr>
+            <p:ph idx="1"/>
+          </p:nvPr>
+        </p:nvSpPr>
+        <p:spPr>
+          <a:xfrm>
+            <a:off x="838200" y="1825625"/>
+            <a:ext cx="3886200" cy="4351338"/>
+          </a:xfrm>
+        </p:spPr>
+        <p:txBody>
+          <a:bodyPr/>
+          <a:lstStyle/>
+          <a:p>
+            <a:r>
+              <a:rPr lang="en-IE" dirty="0"/>
+              <a:t>Click on New Class, and name it</a:t>
+            </a:r>
+          </a:p>
+          <a:p>
+            <a:endParaRPr lang="en-IE" dirty="0"/>
+          </a:p>
+          <a:p>
+            <a:endParaRPr lang="en-IE" dirty="0"/>
+          </a:p>
+        </p:txBody>
+      </p:sp>
+      <p:pic>
+        <p:nvPicPr>
+          <p:cNvPr id="15" name="Picture 14">
+            <a:extLst>
+              <a:ext uri="{FF2B5EF4-FFF2-40B4-BE49-F238E27FC236}">
+                <a16:creationId xmlns:a16="http://schemas.microsoft.com/office/drawing/2014/main" id="{9C8697CD-C7FD-0740-BAE5-5A901F8131AD}"/>
+              </a:ext>
+            </a:extLst>
+          </p:cNvPr>
+          <p:cNvPicPr>
+            <a:picLocks noChangeAspect="1"/>
+          </p:cNvPicPr>
+          <p:nvPr/>
+        </p:nvPicPr>
+        <p:blipFill>
+          <a:blip r:embed="rId2"/>
+          <a:stretch>
+            <a:fillRect/>
+          </a:stretch>
+        </p:blipFill>
+        <p:spPr>
+          <a:xfrm>
+            <a:off x="2362200" y="2667000"/>
+            <a:ext cx="2476846" cy="4134427"/>
+          </a:xfrm>
+          <a:prstGeom prst="rect">
+            <a:avLst/>
+          </a:prstGeom>
+        </p:spPr>
+      </p:pic>
+      <p:pic>
+        <p:nvPicPr>
+          <p:cNvPr id="17" name="Picture 16">
+            <a:extLst>
+              <a:ext uri="{FF2B5EF4-FFF2-40B4-BE49-F238E27FC236}">
+                <a16:creationId xmlns:a16="http://schemas.microsoft.com/office/drawing/2014/main" id="{23025BBB-B915-17E8-078C-5054ADA8FF1F}"/>
+              </a:ext>
+            </a:extLst>
+          </p:cNvPr>
+          <p:cNvPicPr>
+            <a:picLocks noChangeAspect="1"/>
+          </p:cNvPicPr>
+          <p:nvPr/>
+        </p:nvPicPr>
+        <p:blipFill>
+          <a:blip r:embed="rId3"/>
+          <a:stretch>
+            <a:fillRect/>
+          </a:stretch>
+        </p:blipFill>
+        <p:spPr>
+          <a:xfrm>
+            <a:off x="5029200" y="1551792"/>
+            <a:ext cx="7008879" cy="5306208"/>
+          </a:xfrm>
+          <a:prstGeom prst="rect">
+            <a:avLst/>
+          </a:prstGeom>
+        </p:spPr>
+      </p:pic>
+    </p:spTree>
+    <p:extLst>
+      <p:ext uri="{BB962C8B-B14F-4D97-AF65-F5344CB8AC3E}">
+        <p14:creationId xmlns:p14="http://schemas.microsoft.com/office/powerpoint/2010/main" val="3661995497"/>
+      </p:ext>
+    </p:extLst>
+  </p:cSld>
+  <p:clrMapOvr>
+    <a:masterClrMapping/>
+  </p:clrMapOvr>
+  <p:timing>
+    <p:tnLst>
+      <p:par>
+        <p:cTn id="1" dur="indefinite" restart="never" nodeType="tmRoot">
+          <p:childTnLst>
+            <p:seq concurrent="1" nextAc="seek">
+              <p:cTn id="2" dur="indefinite" nodeType="mainSeq">
+                <p:childTnLst>
+                  <p:par>
+                    <p:cTn id="3" fill="hold">
+                      <p:stCondLst>
+                        <p:cond delay="indefinite"/>
+                      </p:stCondLst>
+                      <p:childTnLst>
                         <p:par>
-                          <p:cTn id="23" fill="hold">
+                          <p:cTn id="4" fill="hold">
                             <p:stCondLst>
                               <p:cond delay="0"/>
                             </p:stCondLst>
                             <p:childTnLst>
                               <p:par>
-                                <p:cTn id="24" presetID="1" presetClass="entr" presetSubtype="0" fill="hold" nodeType="afterEffect">
+                                <p:cTn id="5" presetID="1" presetClass="entr" presetSubtype="0" fill="hold" grpId="0" nodeType="clickEffect">
                                   <p:stCondLst>
                                     <p:cond delay="0"/>
                                   </p:stCondLst>
                                   <p:childTnLst>
                                     <p:set>
                                       <p:cBhvr>
-                                        <p:cTn id="25" dur="1" fill="hold">
+                                        <p:cTn id="6" dur="1" fill="hold">
+                                          <p:stCondLst>
+                                            <p:cond delay="0"/>
+                                          </p:stCondLst>
+                                        </p:cTn>
+                                        <p:tgtEl>
+                                          <p:spTgt spid="6">
+                                            <p:txEl>
+                                              <p:pRg st="0" end="0"/>
+                                            </p:txEl>
+                                          </p:spTgt>
+                                        </p:tgtEl>
+                                        <p:attrNameLst>
+                                          <p:attrName>style.visibility</p:attrName>
+                                        </p:attrNameLst>
+                                      </p:cBhvr>
+                                      <p:to>
+                                        <p:strVal val="visible"/>
+                                      </p:to>
+                                    </p:set>
+                                  </p:childTnLst>
+                                </p:cTn>
+                              </p:par>
+                            </p:childTnLst>
+                          </p:cTn>
+                        </p:par>
+                        <p:par>
+                          <p:cTn id="7" fill="hold">
+                            <p:stCondLst>
+                              <p:cond delay="0"/>
+                            </p:stCondLst>
+                            <p:childTnLst>
+                              <p:par>
+                                <p:cTn id="8" presetID="1" presetClass="entr" presetSubtype="0" fill="hold" nodeType="afterEffect">
+                                  <p:stCondLst>
+                                    <p:cond delay="0"/>
+                                  </p:stCondLst>
+                                  <p:childTnLst>
+                                    <p:set>
+                                      <p:cBhvr>
+                                        <p:cTn id="9" dur="1" fill="hold">
                                           <p:stCondLst>
                                             <p:cond delay="0"/>
                                           </p:stCondLst>
@@ -5270,26 +5637,26 @@
                     </p:cTn>
                   </p:par>
                   <p:par>
-                    <p:cTn id="26" fill="hold">
+                    <p:cTn id="10" fill="hold">
                       <p:stCondLst>
                         <p:cond delay="indefinite"/>
                       </p:stCondLst>
                       <p:childTnLst>
                         <p:par>
-                          <p:cTn id="27" fill="hold">
+                          <p:cTn id="11" fill="hold">
                             <p:stCondLst>
                               <p:cond delay="0"/>
                             </p:stCondLst>
                             <p:childTnLst>
                               <p:par>
-                                <p:cTn id="28" presetID="1" presetClass="entr" presetSubtype="0" fill="hold" nodeType="clickEffect">
+                                <p:cTn id="12" presetID="1" presetClass="entr" presetSubtype="0" fill="hold" nodeType="clickEffect">
                                   <p:stCondLst>
                                     <p:cond delay="0"/>
                                   </p:stCondLst>
                                   <p:childTnLst>
                                     <p:set>
                                       <p:cBhvr>
-                                        <p:cTn id="29" dur="1" fill="hold">
+                                        <p:cTn id="13" dur="1" fill="hold">
                                           <p:stCondLst>
                                             <p:cond delay="0"/>
                                           </p:stCondLst>
@@ -5342,7 +5709,7 @@
 </p:sld>
 </file>
 
-<file path=ppt/slides/slide11.xml><?xml version="1.0" encoding="utf-8"?>
+<file path=ppt/slides/slide13.xml><?xml version="1.0" encoding="utf-8"?>
 <p:sld xmlns:a="http://schemas.openxmlformats.org/drawingml/2006/main" xmlns:r="http://schemas.openxmlformats.org/officeDocument/2006/relationships" xmlns:p="http://schemas.openxmlformats.org/presentationml/2006/main">
   <p:cSld>
     <p:spTree>
@@ -5555,7 +5922,7 @@
 </p:sld>
 </file>
 
-<file path=ppt/slides/slide12.xml><?xml version="1.0" encoding="utf-8"?>
+<file path=ppt/slides/slide14.xml><?xml version="1.0" encoding="utf-8"?>
 <p:sld xmlns:a="http://schemas.openxmlformats.org/drawingml/2006/main" xmlns:r="http://schemas.openxmlformats.org/officeDocument/2006/relationships" xmlns:p="http://schemas.openxmlformats.org/presentationml/2006/main">
   <p:cSld>
     <p:spTree>
@@ -5741,7 +6108,7 @@
 </p:sld>
 </file>
 
-<file path=ppt/slides/slide13.xml><?xml version="1.0" encoding="utf-8"?>
+<file path=ppt/slides/slide15.xml><?xml version="1.0" encoding="utf-8"?>
 <p:sld xmlns:a="http://schemas.openxmlformats.org/drawingml/2006/main" xmlns:r="http://schemas.openxmlformats.org/officeDocument/2006/relationships" xmlns:p="http://schemas.openxmlformats.org/presentationml/2006/main">
   <p:cSld>
     <p:spTree>
@@ -5857,7 +6224,7 @@
 </p:sld>
 </file>
 
-<file path=ppt/slides/slide14.xml><?xml version="1.0" encoding="utf-8"?>
+<file path=ppt/slides/slide16.xml><?xml version="1.0" encoding="utf-8"?>
 <p:sld xmlns:a="http://schemas.openxmlformats.org/drawingml/2006/main" xmlns:r="http://schemas.openxmlformats.org/officeDocument/2006/relationships" xmlns:p="http://schemas.openxmlformats.org/presentationml/2006/main">
   <p:cSld>
     <p:spTree>
@@ -5980,7 +6347,7 @@
 </p:sld>
 </file>
 
-<file path=ppt/slides/slide15.xml><?xml version="1.0" encoding="utf-8"?>
+<file path=ppt/slides/slide17.xml><?xml version="1.0" encoding="utf-8"?>
 <p:sld xmlns:a="http://schemas.openxmlformats.org/drawingml/2006/main" xmlns:r="http://schemas.openxmlformats.org/officeDocument/2006/relationships" xmlns:p="http://schemas.openxmlformats.org/presentationml/2006/main">
   <p:cSld>
     <p:spTree>
@@ -6100,7 +6467,7 @@
 </p:sld>
 </file>
 
-<file path=ppt/slides/slide16.xml><?xml version="1.0" encoding="utf-8"?>
+<file path=ppt/slides/slide18.xml><?xml version="1.0" encoding="utf-8"?>
 <p:sld xmlns:a="http://schemas.openxmlformats.org/drawingml/2006/main" xmlns:r="http://schemas.openxmlformats.org/officeDocument/2006/relationships" xmlns:p="http://schemas.openxmlformats.org/presentationml/2006/main">
   <p:cSld>
     <p:spTree>

</xml_diff>